<commit_message>
docs(presentation): remove mobile app references to focus defense on web and API
</commit_message>
<xml_diff>
--- a/Presentacion_Flujo_Canva.pptx
+++ b/Presentacion_Flujo_Canva.pptx
@@ -1679,7 +1679,7 @@
                 <a:ea typeface="Segoe UI" pitchFamily="34" charset="-122"/>
                 <a:cs typeface="Segoe UI" pitchFamily="34" charset="-120"/>
               </a:rPr>
-              <a:t>App Móvil (Flutter)</a:t>
+              <a:t>Backend API (FastAPI)</a:t>
             </a:r>
             <a:endParaRPr lang="en-US" sz="1100" dirty="0"/>
           </a:p>
@@ -1745,7 +1745,7 @@
                 <a:ea typeface="Segoe UI" pitchFamily="34" charset="-122"/>
                 <a:cs typeface="Segoe UI" pitchFamily="34" charset="-120"/>
               </a:rPr>
-              <a:t>Backend API (FastAPI)</a:t>
+              <a:t>Precios Claros (SEPA)</a:t>
             </a:r>
             <a:endParaRPr lang="en-US" sz="1100" dirty="0"/>
           </a:p>
@@ -3391,7 +3391,7 @@
                 <a:ea typeface="Segoe UI" pitchFamily="34" charset="-122"/>
                 <a:cs typeface="Segoe UI" pitchFamily="34" charset="-120"/>
               </a:rPr>
-              <a:t>8. App Móvil (Flutter) + Mercado Pago</a:t>
+              <a:t>8. Sincronización con Mercado Pago</a:t>
             </a:r>
             <a:endParaRPr lang="en-US" sz="1400" dirty="0"/>
           </a:p>
@@ -3430,7 +3430,7 @@
                 <a:ea typeface="Segoe UI" pitchFamily="34" charset="-122"/>
                 <a:cs typeface="Segoe UI" pitchFamily="34" charset="-120"/>
               </a:rPr>
-              <a:t>Versión para celular Android conectada al mismo servidor que la Web, más sincronización directa con Mercado Pago para traer tus gastos reales sin duplicarlos.</a:t>
+              <a:t>Conexión directa con la API de Mercado Pago mediante un adaptador propio para importar tus gastos reales automáticamente sin duplicarlos.</a:t>
             </a:r>
             <a:endParaRPr lang="en-US" sz="1150" dirty="0"/>
           </a:p>
@@ -3750,7 +3750,7 @@
                 <a:ea typeface="Segoe UI" pitchFamily="34" charset="-122"/>
                 <a:cs typeface="Segoe UI" pitchFamily="34" charset="-120"/>
               </a:rPr>
-              <a:t>Página Web</a:t>
+              <a:t>Vistas y Diseño</a:t>
             </a:r>
             <a:endParaRPr lang="en-US" sz="1150" dirty="0"/>
           </a:p>
@@ -3789,7 +3789,7 @@
                 <a:ea typeface="Segoe UI" pitchFamily="34" charset="-122"/>
                 <a:cs typeface="Segoe UI" pitchFamily="34" charset="-120"/>
               </a:rPr>
-              <a:t>HTML, CSS y TypeScript</a:t>
+              <a:t>HTML y CSS Modular</a:t>
             </a:r>
             <a:endParaRPr lang="en-US" sz="1000" dirty="0"/>
           </a:p>
@@ -3855,7 +3855,7 @@
                 <a:ea typeface="Segoe UI" pitchFamily="34" charset="-122"/>
                 <a:cs typeface="Segoe UI" pitchFamily="34" charset="-120"/>
               </a:rPr>
-              <a:t>App Celular</a:t>
+              <a:t>Lógica de Pantalla</a:t>
             </a:r>
             <a:endParaRPr lang="en-US" sz="1150" dirty="0"/>
           </a:p>
@@ -3894,7 +3894,7 @@
                 <a:ea typeface="Segoe UI" pitchFamily="34" charset="-122"/>
                 <a:cs typeface="Segoe UI" pitchFamily="34" charset="-120"/>
               </a:rPr>
-              <a:t>Flutter (Android)</a:t>
+              <a:t>TypeScript + Estado Central</a:t>
             </a:r>
             <a:endParaRPr lang="en-US" sz="1000" dirty="0"/>
           </a:p>
@@ -5232,7 +5232,7 @@
                 <a:ea typeface="Segoe UI" pitchFamily="34" charset="-122"/>
                 <a:cs typeface="Segoe UI" pitchFamily="34" charset="-120"/>
               </a:rPr>
-              <a:t>Un solo Backend para Web y Celular</a:t>
+              <a:t>Separar el Frontend (Web) del Backend (API)</a:t>
             </a:r>
             <a:endParaRPr lang="en-US" sz="1350" dirty="0"/>
           </a:p>
@@ -5271,7 +5271,7 @@
                 <a:ea typeface="Segoe UI" pitchFamily="34" charset="-122"/>
                 <a:cs typeface="Segoe UI" pitchFamily="34" charset="-120"/>
               </a:rPr>
-              <a:t>En vez de programar las cuentas dos veces, pusimos toda la lógica en el servidor con FastAPI. Así, cualquier cambio impacta en la Web y en Android al mismo tiempo.</a:t>
+              <a:t>Las pantallas solo muestran datos y toda la lógica pesada (cálculos, saldos, IA y precios) corre en el servidor con FastAPI. Así la página es rápida y segura.</a:t>
             </a:r>
             <a:endParaRPr lang="en-US" sz="1100" dirty="0"/>
           </a:p>
@@ -5945,7 +5945,7 @@
                 <a:ea typeface="Segoe UI" pitchFamily="34" charset="-122"/>
                 <a:cs typeface="Segoe UI" pitchFamily="34" charset="-120"/>
               </a:rPr>
-              <a:t>Un proyecto pensado para resolver un problema real del bolsillo, construido de forma ordenada, escalable y multiplataforma.</a:t>
+              <a:t>Un proyecto pensado para resolver un problema real del bolsillo, construido de forma ordenada y escalable.</a:t>
             </a:r>
             <a:endParaRPr lang="en-US" sz="1500" dirty="0"/>
           </a:p>
@@ -6116,7 +6116,7 @@
                 <a:ea typeface="Segoe UI" pitchFamily="34" charset="-122"/>
                 <a:cs typeface="Segoe UI" pitchFamily="34" charset="-120"/>
               </a:rPr>
-              <a:t>Web + Móvil</a:t>
+              <a:t>Frontend + API</a:t>
             </a:r>
             <a:endParaRPr lang="en-US" sz="1800" dirty="0"/>
           </a:p>
@@ -6155,7 +6155,7 @@
                 <a:ea typeface="Segoe UI" pitchFamily="34" charset="-122"/>
                 <a:cs typeface="Segoe UI" pitchFamily="34" charset="-120"/>
               </a:rPr>
-              <a:t>Conectados a la misma API</a:t>
+              <a:t>Rápido, seguro y separado</a:t>
             </a:r>
             <a:endParaRPr lang="en-US" sz="1100" dirty="0"/>
           </a:p>

</xml_diff>